<commit_message>
Release v1.0.0 — AI-Assisted Architecture framework
Complete platform-as-product enterprise architecture framework with:
- 13 standards (traceability, strategy, platform, capability, context, ABB, SBB, service, visual design, diagrams)
- 7 AI agent skills for creating architecture artefacts
- Foundation seed: 12 platforms, 44 capabilities, 12 bounded contexts, 8 ABBs, 3 SBBs, 13 outcomes
- IDE integration for Claude Code, Cursor, GitHub Copilot, Gemini, Cline, Windsurf
- Domain concept fully replaced by Platform (Team Topologies, CNCF, Gartner alignment)
- Draw.io diagrams with 300 DPI PNG export
- PowerPoint generation for building block summary slides

Co-Authored-By: Claude Opus 4.6 <noreply@anthropic.com>
</commit_message>
<xml_diff>
--- a/foundation/building-blocks/solution-building-blocks/SB-001/components-and-summary.pptx
+++ b/foundation/building-blocks/solution-building-blocks/SB-001/components-and-summary.pptx
@@ -3140,7 +3140,7 @@
         <p:spPr>
           <a:xfrm>
             <a:off x="223637" y="720989"/>
-            <a:ext cx="5491194" cy="5491194"/>
+            <a:ext cx="5552207" cy="5491194"/>
           </a:xfrm>
           <a:prstGeom prst="rect">
             <a:avLst/>
@@ -3149,14 +3149,14 @@
       </p:pic>
       <p:pic>
         <p:nvPicPr>
-          <p:cNvPr id="4" name="Picture 3" descr="components.png"/>
+          <p:cNvPr id="4" name="Picture 3" descr="summary.png"/>
           <p:cNvPicPr>
             <a:picLocks noChangeAspect="1"/>
           </p:cNvPicPr>
           <p:nvPr/>
         </p:nvPicPr>
         <p:blipFill>
-          <a:blip r:embed="rId2"/>
+          <a:blip r:embed="rId3"/>
           <a:stretch>
             <a:fillRect/>
           </a:stretch>
@@ -3164,7 +3164,7 @@
         <p:spPr>
           <a:xfrm>
             <a:off x="6516759" y="669618"/>
-            <a:ext cx="5387458" cy="5387458"/>
+            <a:ext cx="3364948" cy="5970613"/>
           </a:xfrm>
           <a:prstGeom prst="rect">
             <a:avLst/>

</xml_diff>